<commit_message>
docs: finalize public hackathon delivery
</commit_message>
<xml_diff>
--- a/deliverables/EcoLoop_Building_Agents_Presentation.pptx
+++ b/deliverables/EcoLoop_Building_Agents_Presentation.pptx
@@ -2,18 +2,18 @@
 <file path=ppt/presentation.xml><?xml version="1.0" encoding="utf-8"?>
 <p:presentation xmlns:p="http://schemas.openxmlformats.org/presentationml/2006/main">
   <p:sldMasterIdLst>
-    <p:sldMasterId xmlns:r="http://schemas.openxmlformats.org/officeDocument/2006/relationships" id="2147483648" r:id="R51265987235e45ee"/>
+    <p:sldMasterId xmlns:r="http://schemas.openxmlformats.org/officeDocument/2006/relationships" id="2147483648" r:id="R68a4cbab4dae4556"/>
   </p:sldMasterIdLst>
   <p:notesMasterIdLst>
-    <p:notesMasterId xmlns:r="http://schemas.openxmlformats.org/officeDocument/2006/relationships" r:id="Ra31d8f9ba0ca48aa"/>
+    <p:notesMasterId xmlns:r="http://schemas.openxmlformats.org/officeDocument/2006/relationships" r:id="Ra14a36d8c3a14713"/>
   </p:notesMasterIdLst>
   <p:sldIdLst>
-    <p:sldId xmlns:r="http://schemas.openxmlformats.org/officeDocument/2006/relationships" id="256" r:id="Ra69e7337386e47c6"/>
-    <p:sldId xmlns:r="http://schemas.openxmlformats.org/officeDocument/2006/relationships" id="257" r:id="Ra1b3e8360ebf44c2"/>
-    <p:sldId xmlns:r="http://schemas.openxmlformats.org/officeDocument/2006/relationships" id="258" r:id="Re8c11dadb154477f"/>
-    <p:sldId xmlns:r="http://schemas.openxmlformats.org/officeDocument/2006/relationships" id="259" r:id="R0a3dd86a0570449b"/>
-    <p:sldId xmlns:r="http://schemas.openxmlformats.org/officeDocument/2006/relationships" id="260" r:id="Rf7600025a6a24e60"/>
-    <p:sldId xmlns:r="http://schemas.openxmlformats.org/officeDocument/2006/relationships" id="261" r:id="Rd7a30a1e24574878"/>
+    <p:sldId xmlns:r="http://schemas.openxmlformats.org/officeDocument/2006/relationships" id="256" r:id="R12f78b9a2769470a"/>
+    <p:sldId xmlns:r="http://schemas.openxmlformats.org/officeDocument/2006/relationships" id="257" r:id="R5f2787451e434b93"/>
+    <p:sldId xmlns:r="http://schemas.openxmlformats.org/officeDocument/2006/relationships" id="258" r:id="Rc419d35a30a54bc4"/>
+    <p:sldId xmlns:r="http://schemas.openxmlformats.org/officeDocument/2006/relationships" id="259" r:id="R93e85456e1ee4684"/>
+    <p:sldId xmlns:r="http://schemas.openxmlformats.org/officeDocument/2006/relationships" id="260" r:id="R09944f1b4cff47b3"/>
+    <p:sldId xmlns:r="http://schemas.openxmlformats.org/officeDocument/2006/relationships" id="261" r:id="R460cec07c0ac41d1"/>
   </p:sldIdLst>
   <p:sldSz cx="12192000" cy="6858000"/>
   <p:notesSz cx="6858000" cy="9144000"/>
@@ -4405,17 +4405,17 @@
   </p:cSld>
   <p:clrMap bg1="lt1" tx1="dk1" bg2="lt2" tx2="dk2" accent1="accent1" accent2="accent2" accent3="accent3" accent4="accent4" accent5="accent5" accent6="accent6" hlink="hlink" folHlink="folHlink"/>
   <p:sldLayoutIdLst>
-    <p:sldLayoutId xmlns:r="http://schemas.openxmlformats.org/officeDocument/2006/relationships" id="2147483649" r:id="Rf41f101f26204e33"/>
-    <p:sldLayoutId xmlns:r="http://schemas.openxmlformats.org/officeDocument/2006/relationships" id="2147483650" r:id="Rb787c1983bf342c9"/>
-    <p:sldLayoutId xmlns:r="http://schemas.openxmlformats.org/officeDocument/2006/relationships" id="2147483651" r:id="R57966ef84c7142d8"/>
-    <p:sldLayoutId xmlns:r="http://schemas.openxmlformats.org/officeDocument/2006/relationships" id="2147483652" r:id="R52cfc937e7d54a29"/>
-    <p:sldLayoutId xmlns:r="http://schemas.openxmlformats.org/officeDocument/2006/relationships" id="2147483653" r:id="R66af56f117a94db0"/>
-    <p:sldLayoutId xmlns:r="http://schemas.openxmlformats.org/officeDocument/2006/relationships" id="2147483654" r:id="Rf3c728b214944449"/>
-    <p:sldLayoutId xmlns:r="http://schemas.openxmlformats.org/officeDocument/2006/relationships" id="2147483655" r:id="R41ebb54a3aad4157"/>
-    <p:sldLayoutId xmlns:r="http://schemas.openxmlformats.org/officeDocument/2006/relationships" id="2147483656" r:id="R2884474818da4ff1"/>
-    <p:sldLayoutId xmlns:r="http://schemas.openxmlformats.org/officeDocument/2006/relationships" id="2147483657" r:id="R34c0a1cf08af409c"/>
-    <p:sldLayoutId xmlns:r="http://schemas.openxmlformats.org/officeDocument/2006/relationships" id="2147483658" r:id="R170cdf54e48e495e"/>
-    <p:sldLayoutId xmlns:r="http://schemas.openxmlformats.org/officeDocument/2006/relationships" id="2147483659" r:id="Ra3efc750e77e40d7"/>
+    <p:sldLayoutId xmlns:r="http://schemas.openxmlformats.org/officeDocument/2006/relationships" id="2147483649" r:id="Rdbbabf95c1114d81"/>
+    <p:sldLayoutId xmlns:r="http://schemas.openxmlformats.org/officeDocument/2006/relationships" id="2147483650" r:id="R92108acf8b524a4f"/>
+    <p:sldLayoutId xmlns:r="http://schemas.openxmlformats.org/officeDocument/2006/relationships" id="2147483651" r:id="R8e03bc8ba949482a"/>
+    <p:sldLayoutId xmlns:r="http://schemas.openxmlformats.org/officeDocument/2006/relationships" id="2147483652" r:id="R17bcf2da5f044cef"/>
+    <p:sldLayoutId xmlns:r="http://schemas.openxmlformats.org/officeDocument/2006/relationships" id="2147483653" r:id="R9263b54fb9254589"/>
+    <p:sldLayoutId xmlns:r="http://schemas.openxmlformats.org/officeDocument/2006/relationships" id="2147483654" r:id="Rd534b1020adc4e17"/>
+    <p:sldLayoutId xmlns:r="http://schemas.openxmlformats.org/officeDocument/2006/relationships" id="2147483655" r:id="Ra4ebe8cc553249ff"/>
+    <p:sldLayoutId xmlns:r="http://schemas.openxmlformats.org/officeDocument/2006/relationships" id="2147483656" r:id="R63583b3fa9004e2c"/>
+    <p:sldLayoutId xmlns:r="http://schemas.openxmlformats.org/officeDocument/2006/relationships" id="2147483657" r:id="R063fcaf646994980"/>
+    <p:sldLayoutId xmlns:r="http://schemas.openxmlformats.org/officeDocument/2006/relationships" id="2147483658" r:id="R905e80d681404097"/>
+    <p:sldLayoutId xmlns:r="http://schemas.openxmlformats.org/officeDocument/2006/relationships" id="2147483659" r:id="R9509979367d7414f"/>
   </p:sldLayoutIdLst>
   <p:hf hdr="0" dt="0"/>
   <p:txStyles>
@@ -5501,7 +5501,7 @@
                 <a:ea typeface="Arial"/>
                 <a:cs typeface="Arial"/>
               </a:rPr>
-              <a:t>Student – Pragadesh V</a:t>
+              <a:t>Student – Gokulan Malli Jayaprakash</a:t>
             </a:r>
           </a:p>
           <a:p xmlns:a="http://schemas.openxmlformats.org/drawingml/2006/main">
@@ -5518,7 +5518,7 @@
                 <a:ea typeface="Arial"/>
                 <a:cs typeface="Arial"/>
               </a:rPr>
-              <a:t>ID – 2303917710421113</a:t>
+              <a:t>ID – C10421040</a:t>
             </a:r>
           </a:p>
         </p:txBody>
@@ -5767,7 +5767,7 @@
           <p:nvPr/>
         </p:nvPicPr>
         <p:blipFill>
-          <a:blip xmlns:r="http://schemas.openxmlformats.org/officeDocument/2006/relationships" xmlns:a="http://schemas.openxmlformats.org/drawingml/2006/main" r:embed="Rba72a5c509a1460c"/>
+          <a:blip xmlns:r="http://schemas.openxmlformats.org/officeDocument/2006/relationships" xmlns:a="http://schemas.openxmlformats.org/drawingml/2006/main" r:embed="R00182cb885f141d2"/>
           <a:stretch xmlns:a="http://schemas.openxmlformats.org/drawingml/2006/main"/>
         </p:blipFill>
         <p:spPr>
@@ -5985,7 +5985,7 @@
           <p:nvPr/>
         </p:nvPicPr>
         <p:blipFill>
-          <a:blip xmlns:r="http://schemas.openxmlformats.org/officeDocument/2006/relationships" xmlns:a="http://schemas.openxmlformats.org/drawingml/2006/main" r:embed="R7f3723d23390438f"/>
+          <a:blip xmlns:r="http://schemas.openxmlformats.org/officeDocument/2006/relationships" xmlns:a="http://schemas.openxmlformats.org/drawingml/2006/main" r:embed="Ra1601b3c77c0438d"/>
           <a:stretch xmlns:a="http://schemas.openxmlformats.org/drawingml/2006/main"/>
         </p:blipFill>
         <p:spPr>
@@ -6301,7 +6301,7 @@
           <p:nvPr/>
         </p:nvPicPr>
         <p:blipFill>
-          <a:blip xmlns:r="http://schemas.openxmlformats.org/officeDocument/2006/relationships" xmlns:a="http://schemas.openxmlformats.org/drawingml/2006/main" r:embed="Raf08a78ea134443b"/>
+          <a:blip xmlns:r="http://schemas.openxmlformats.org/officeDocument/2006/relationships" xmlns:a="http://schemas.openxmlformats.org/drawingml/2006/main" r:embed="Ra2de6b2973d842b7"/>
           <a:stretch xmlns:a="http://schemas.openxmlformats.org/drawingml/2006/main"/>
         </p:blipFill>
         <p:spPr>
@@ -6629,7 +6629,7 @@
           <p:nvPr/>
         </p:nvPicPr>
         <p:blipFill>
-          <a:blip xmlns:r="http://schemas.openxmlformats.org/officeDocument/2006/relationships" xmlns:a="http://schemas.openxmlformats.org/drawingml/2006/main" r:embed="Ra5ddad3320044c62"/>
+          <a:blip xmlns:r="http://schemas.openxmlformats.org/officeDocument/2006/relationships" xmlns:a="http://schemas.openxmlformats.org/drawingml/2006/main" r:embed="Rad8c649e0be64619"/>
           <a:stretch xmlns:a="http://schemas.openxmlformats.org/drawingml/2006/main"/>
         </p:blipFill>
         <p:spPr>
@@ -6651,7 +6651,7 @@
           <p:nvPr/>
         </p:nvPicPr>
         <p:blipFill>
-          <a:blip xmlns:r="http://schemas.openxmlformats.org/officeDocument/2006/relationships" xmlns:a="http://schemas.openxmlformats.org/drawingml/2006/main" r:embed="R96b89fd670724c71"/>
+          <a:blip xmlns:r="http://schemas.openxmlformats.org/officeDocument/2006/relationships" xmlns:a="http://schemas.openxmlformats.org/drawingml/2006/main" r:embed="Rbdc32dd20f10451e"/>
           <a:stretch xmlns:a="http://schemas.openxmlformats.org/drawingml/2006/main"/>
         </p:blipFill>
         <p:spPr>
@@ -6673,7 +6673,7 @@
           <p:nvPr/>
         </p:nvPicPr>
         <p:blipFill>
-          <a:blip xmlns:r="http://schemas.openxmlformats.org/officeDocument/2006/relationships" xmlns:a="http://schemas.openxmlformats.org/drawingml/2006/main" r:embed="Rd458dc210a7c4893"/>
+          <a:blip xmlns:r="http://schemas.openxmlformats.org/officeDocument/2006/relationships" xmlns:a="http://schemas.openxmlformats.org/drawingml/2006/main" r:embed="Rb787950a72a14148"/>
           <a:stretch xmlns:a="http://schemas.openxmlformats.org/drawingml/2006/main"/>
         </p:blipFill>
         <p:spPr>

</xml_diff>